<commit_message>
started js game code, base is almost done
</commit_message>
<xml_diff>
--- a/Assets/ProjectPresentation.pptx
+++ b/Assets/ProjectPresentation.pptx
@@ -6482,7 +6482,7 @@
         <p:spPr>
           <a:xfrm>
             <a:off x="5872453" y="3698377"/>
-            <a:ext cx="5268351" cy="2308324"/>
+            <a:ext cx="5268351" cy="2862322"/>
           </a:xfrm>
           <a:prstGeom prst="rect">
             <a:avLst/>
@@ -6508,6 +6508,16 @@
             <a:r>
               <a:rPr lang="en-US" dirty="0"/>
               <a:t>I bet, you noticed already the dark area, the reason is, I keep the game completely hidden, although, to make it more interesting I’ve left small areas that could hint you towards what is this game going to be.</a:t>
+            </a:r>
+            <a:br>
+              <a:rPr lang="en-US" dirty="0"/>
+            </a:br>
+            <a:br>
+              <a:rPr lang="en-US" dirty="0"/>
+            </a:br>
+            <a:r>
+              <a:rPr lang="en-US" dirty="0"/>
+              <a:t>The idea is related to colors. Hope you win!</a:t>
             </a:r>
             <a:endParaRPr lang="en-FI" dirty="0"/>
           </a:p>

</xml_diff>